<commit_message>
Redesign left panel as logic flow diagram (routing, branching, feedback loops)
Co-authored-by: Congying Zhang <JasonZhangcy@users.noreply.github.com>
</commit_message>
<xml_diff>
--- a/Agent_Team_OBP规划.pptx
+++ b/Agent_Team_OBP规划.pptx
@@ -3105,7 +3105,7 @@
           <a:noFill/>
         </p:spPr>
         <p:txBody>
-          <a:bodyPr wrap="square" anchor="ctr" lIns="50800" rIns="50800" tIns="25400" bIns="25400">
+          <a:bodyPr wrap="square" anchor="ctr" lIns="25400" rIns="25400" tIns="12700" bIns="12700">
             <a:spAutoFit/>
           </a:bodyPr>
           <a:lstStyle/>
@@ -3141,7 +3141,7 @@
           <a:noFill/>
         </p:spPr>
         <p:txBody>
-          <a:bodyPr wrap="square" anchor="ctr" lIns="50800" rIns="50800" tIns="25400" bIns="25400">
+          <a:bodyPr wrap="square" anchor="ctr" lIns="25400" rIns="25400" tIns="12700" bIns="12700">
             <a:spAutoFit/>
           </a:bodyPr>
           <a:lstStyle/>
@@ -3221,7 +3221,7 @@
           <a:noFill/>
         </p:spPr>
         <p:txBody>
-          <a:bodyPr wrap="square" anchor="ctr" lIns="50800" rIns="50800" tIns="25400" bIns="25400">
+          <a:bodyPr wrap="square" anchor="ctr" lIns="25400" rIns="25400" tIns="12700" bIns="12700">
             <a:spAutoFit/>
           </a:bodyPr>
           <a:lstStyle/>
@@ -3242,18 +3242,72 @@
       </p:sp>
       <p:sp>
         <p:nvSpPr>
-          <p:cNvPr id="6" name="Rounded Rectangle 5"/>
+          <p:cNvPr id="6" name="Oval 5"/>
           <p:cNvSpPr/>
           <p:nvPr/>
         </p:nvSpPr>
         <p:spPr>
           <a:xfrm>
-            <a:off x="1234440" y="1316736"/>
-            <a:ext cx="4526280" cy="402336"/>
+            <a:off x="457200" y="1371600"/>
+            <a:ext cx="475488" cy="438912"/>
+          </a:xfrm>
+          <a:prstGeom prst="ellipse">
+            <a:avLst/>
+          </a:prstGeom>
+          <a:solidFill>
+            <a:srgbClr val="1F2A3A"/>
+          </a:solidFill>
+          <a:ln>
+            <a:noFill/>
+          </a:ln>
+          <a:effectLst/>
+        </p:spPr>
+        <p:style>
+          <a:lnRef idx="1">
+            <a:schemeClr val="accent1"/>
+          </a:lnRef>
+          <a:fillRef idx="3">
+            <a:schemeClr val="accent1"/>
+          </a:fillRef>
+          <a:effectRef idx="2">
+            <a:schemeClr val="accent1"/>
+          </a:effectRef>
+          <a:fontRef idx="minor">
+            <a:schemeClr val="lt1"/>
+          </a:fontRef>
+        </p:style>
+        <p:txBody>
+          <a:bodyPr rtlCol="0" anchor="ctr" wrap="square" lIns="25400" rIns="25400" tIns="12700" bIns="12700"/>
+          <a:lstStyle/>
+          <a:p>
+            <a:pPr algn="ctr"/>
+            <a:r>
+              <a:rPr sz="950" b="1">
+                <a:solidFill>
+                  <a:srgbClr val="FFFFFF"/>
+                </a:solidFill>
+                <a:latin typeface="微软雅黑"/>
+                <a:ea typeface="微软雅黑"/>
+              </a:rPr>
+              <a:t>用户</a:t>
+            </a:r>
+          </a:p>
+        </p:txBody>
+      </p:sp>
+      <p:sp>
+        <p:nvSpPr>
+          <p:cNvPr id="7" name="Rounded Rectangle 6"/>
+          <p:cNvSpPr/>
+          <p:nvPr/>
+        </p:nvSpPr>
+        <p:spPr>
+          <a:xfrm>
+            <a:off x="1828800" y="1371600"/>
+            <a:ext cx="2468880" cy="438912"/>
           </a:xfrm>
           <a:prstGeom prst="roundRect">
             <a:avLst>
-              <a:gd name="adj" fmla="val 8000"/>
+              <a:gd name="adj" fmla="val 12000"/>
             </a:avLst>
           </a:prstGeom>
           <a:solidFill>
@@ -3279,7 +3333,7 @@
           </a:fontRef>
         </p:style>
         <p:txBody>
-          <a:bodyPr rtlCol="0" anchor="ctr" wrap="square" lIns="50800" rIns="50800" tIns="25400" bIns="25400"/>
+          <a:bodyPr rtlCol="0" anchor="ctr" wrap="square" lIns="25400" rIns="25400" tIns="12700" bIns="12700"/>
           <a:lstStyle/>
           <a:p>
             <a:pPr algn="ctr"/>
@@ -3291,458 +3345,74 @@
                 <a:latin typeface="微软雅黑"/>
                 <a:ea typeface="微软雅黑"/>
               </a:rPr>
-              <a:t>统一任务入口:自然语言描述任务,免选单 Agent / Agent Team</a:t>
-            </a:r>
-          </a:p>
-        </p:txBody>
-      </p:sp>
-      <p:sp>
-        <p:nvSpPr>
-          <p:cNvPr id="7" name="Rounded Rectangle 6"/>
-          <p:cNvSpPr/>
-          <p:nvPr/>
-        </p:nvSpPr>
-        <p:spPr>
-          <a:xfrm>
-            <a:off x="320040" y="1316736"/>
-            <a:ext cx="841248" cy="402336"/>
-          </a:xfrm>
-          <a:prstGeom prst="roundRect">
-            <a:avLst>
-              <a:gd name="adj" fmla="val 8000"/>
-            </a:avLst>
-          </a:prstGeom>
-          <a:solidFill>
-            <a:srgbClr val="6B4FA0"/>
-          </a:solidFill>
-          <a:ln>
-            <a:noFill/>
-          </a:ln>
-          <a:effectLst/>
-        </p:spPr>
-        <p:style>
-          <a:lnRef idx="1">
-            <a:schemeClr val="accent1"/>
-          </a:lnRef>
-          <a:fillRef idx="3">
-            <a:schemeClr val="accent1"/>
-          </a:fillRef>
-          <a:effectRef idx="2">
-            <a:schemeClr val="accent1"/>
-          </a:effectRef>
-          <a:fontRef idx="minor">
-            <a:schemeClr val="lt1"/>
-          </a:fontRef>
-        </p:style>
-        <p:txBody>
-          <a:bodyPr rtlCol="0" anchor="ctr" wrap="square" lIns="50800" rIns="50800" tIns="25400" bIns="25400"/>
-          <a:lstStyle/>
+              <a:t>统一任务入口</a:t>
+            </a:r>
+          </a:p>
           <a:p>
             <a:pPr algn="ctr"/>
             <a:r>
-              <a:rPr sz="1150" b="1">
+              <a:rPr sz="800" b="0">
                 <a:solidFill>
                   <a:srgbClr val="FFFFFF"/>
                 </a:solidFill>
                 <a:latin typeface="微软雅黑"/>
                 <a:ea typeface="微软雅黑"/>
               </a:rPr>
-              <a:t>入口</a:t>
-            </a:r>
-          </a:p>
-        </p:txBody>
-      </p:sp>
-      <p:sp>
-        <p:nvSpPr>
-          <p:cNvPr id="8" name="Rounded Rectangle 7"/>
+              <a:t>自然语言描述,免选执行模式</a:t>
+            </a:r>
+          </a:p>
+        </p:txBody>
+      </p:sp>
+      <p:cxnSp>
+        <p:nvCxnSpPr>
+          <p:cNvPr id="8" name="Connector 7"/>
+          <p:cNvCxnSpPr/>
+          <p:nvPr/>
+        </p:nvCxnSpPr>
+        <p:spPr>
+          <a:xfrm>
+            <a:off x="932688" y="1591056"/>
+            <a:ext cx="896112" cy="0"/>
+          </a:xfrm>
+          <a:prstGeom prst="line">
+            <a:avLst/>
+          </a:prstGeom>
+          <a:ln w="19050">
+            <a:solidFill>
+              <a:srgbClr val="1F2A3A"/>
+            </a:solidFill>
+            <a:tailEnd type="triangle" w="med" len="med"/>
+          </a:ln>
+          <a:effectLst/>
+        </p:spPr>
+        <p:style>
+          <a:lnRef idx="2">
+            <a:schemeClr val="accent1"/>
+          </a:lnRef>
+          <a:fillRef idx="0">
+            <a:schemeClr val="accent1"/>
+          </a:fillRef>
+          <a:effectRef idx="1">
+            <a:schemeClr val="accent1"/>
+          </a:effectRef>
+          <a:fontRef idx="minor">
+            <a:schemeClr val="tx1"/>
+          </a:fontRef>
+        </p:style>
+      </p:cxnSp>
+      <p:sp>
+        <p:nvSpPr>
+          <p:cNvPr id="9" name="Diamond 8"/>
           <p:cNvSpPr/>
           <p:nvPr/>
         </p:nvSpPr>
         <p:spPr>
           <a:xfrm>
-            <a:off x="320040" y="1783080"/>
-            <a:ext cx="841248" cy="932688"/>
-          </a:xfrm>
-          <a:prstGeom prst="roundRect">
-            <a:avLst>
-              <a:gd name="adj" fmla="val 8000"/>
-            </a:avLst>
-          </a:prstGeom>
-          <a:solidFill>
-            <a:srgbClr val="2C5F9E"/>
-          </a:solidFill>
-          <a:ln>
-            <a:noFill/>
-          </a:ln>
-          <a:effectLst/>
-        </p:spPr>
-        <p:style>
-          <a:lnRef idx="1">
-            <a:schemeClr val="accent1"/>
-          </a:lnRef>
-          <a:fillRef idx="3">
-            <a:schemeClr val="accent1"/>
-          </a:fillRef>
-          <a:effectRef idx="2">
-            <a:schemeClr val="accent1"/>
-          </a:effectRef>
-          <a:fontRef idx="minor">
-            <a:schemeClr val="lt1"/>
-          </a:fontRef>
-        </p:style>
-        <p:txBody>
-          <a:bodyPr rtlCol="0" anchor="ctr" wrap="square" lIns="50800" rIns="50800" tIns="25400" bIns="25400"/>
-          <a:lstStyle/>
-          <a:p>
-            <a:pPr algn="ctr"/>
-            <a:r>
-              <a:rPr sz="1150" b="1">
-                <a:solidFill>
-                  <a:srgbClr val="FFFFFF"/>
-                </a:solidFill>
-                <a:latin typeface="微软雅黑"/>
-                <a:ea typeface="微软雅黑"/>
-              </a:rPr>
-              <a:t>体验层</a:t>
-            </a:r>
-          </a:p>
-        </p:txBody>
-      </p:sp>
-      <p:sp>
-        <p:nvSpPr>
-          <p:cNvPr id="9" name="Rounded Rectangle 8"/>
-          <p:cNvSpPr/>
-          <p:nvPr/>
-        </p:nvSpPr>
-        <p:spPr>
-          <a:xfrm>
-            <a:off x="1234440" y="1783080"/>
-            <a:ext cx="4526280" cy="932688"/>
-          </a:xfrm>
-          <a:prstGeom prst="roundRect">
-            <a:avLst>
-              <a:gd name="adj" fmla="val 8000"/>
-            </a:avLst>
-          </a:prstGeom>
-          <a:solidFill>
-            <a:srgbClr val="F2F5F9"/>
-          </a:solidFill>
-          <a:ln w="12700">
-            <a:solidFill>
-              <a:srgbClr val="2C5F9E"/>
-            </a:solidFill>
-          </a:ln>
-          <a:effectLst/>
-        </p:spPr>
-        <p:style>
-          <a:lnRef idx="1">
-            <a:schemeClr val="accent1"/>
-          </a:lnRef>
-          <a:fillRef idx="3">
-            <a:schemeClr val="accent1"/>
-          </a:fillRef>
-          <a:effectRef idx="2">
-            <a:schemeClr val="accent1"/>
-          </a:effectRef>
-          <a:fontRef idx="minor">
-            <a:schemeClr val="lt1"/>
-          </a:fontRef>
-        </p:style>
-        <p:txBody>
-          <a:bodyPr rtlCol="0" anchor="ctr"/>
-          <a:lstStyle/>
-          <a:p>
-            <a:pPr algn="ctr"/>
-          </a:p>
-        </p:txBody>
-      </p:sp>
-      <p:sp>
-        <p:nvSpPr>
-          <p:cNvPr id="10" name="TextBox 9"/>
-          <p:cNvSpPr txBox="1"/>
-          <p:nvPr/>
-        </p:nvSpPr>
-        <p:spPr>
-          <a:xfrm>
-            <a:off x="1307592" y="1801368"/>
-            <a:ext cx="4379976" cy="237744"/>
-          </a:xfrm>
-          <a:prstGeom prst="rect">
+            <a:off x="2240280" y="1993392"/>
+            <a:ext cx="1645920" cy="804672"/>
+          </a:xfrm>
+          <a:prstGeom prst="diamond">
             <a:avLst/>
-          </a:prstGeom>
-          <a:noFill/>
-        </p:spPr>
-        <p:txBody>
-          <a:bodyPr wrap="square" anchor="ctr" lIns="50800" rIns="50800" tIns="25400" bIns="25400">
-            <a:spAutoFit/>
-          </a:bodyPr>
-          <a:lstStyle/>
-          <a:p>
-            <a:pPr algn="l"/>
-            <a:r>
-              <a:rPr sz="1100" b="1">
-                <a:solidFill>
-                  <a:srgbClr val="2C5F9E"/>
-                </a:solidFill>
-                <a:latin typeface="微软雅黑"/>
-                <a:ea typeface="微软雅黑"/>
-              </a:rPr>
-              <a:t>专家 / 专家团(降低使用门槛,资产化运营)</a:t>
-            </a:r>
-          </a:p>
-        </p:txBody>
-      </p:sp>
-      <p:sp>
-        <p:nvSpPr>
-          <p:cNvPr id="11" name="Rounded Rectangle 10"/>
-          <p:cNvSpPr/>
-          <p:nvPr/>
-        </p:nvSpPr>
-        <p:spPr>
-          <a:xfrm>
-            <a:off x="1307592" y="2057400"/>
-            <a:ext cx="1053846" cy="621792"/>
-          </a:xfrm>
-          <a:prstGeom prst="roundRect">
-            <a:avLst>
-              <a:gd name="adj" fmla="val 16000"/>
-            </a:avLst>
-          </a:prstGeom>
-          <a:solidFill>
-            <a:srgbClr val="FFFFFF"/>
-          </a:solidFill>
-          <a:ln w="12700">
-            <a:solidFill>
-              <a:srgbClr val="2C5F9E"/>
-            </a:solidFill>
-          </a:ln>
-          <a:effectLst/>
-        </p:spPr>
-        <p:style>
-          <a:lnRef idx="1">
-            <a:schemeClr val="accent1"/>
-          </a:lnRef>
-          <a:fillRef idx="3">
-            <a:schemeClr val="accent1"/>
-          </a:fillRef>
-          <a:effectRef idx="2">
-            <a:schemeClr val="accent1"/>
-          </a:effectRef>
-          <a:fontRef idx="minor">
-            <a:schemeClr val="lt1"/>
-          </a:fontRef>
-        </p:style>
-        <p:txBody>
-          <a:bodyPr rtlCol="0" anchor="ctr" wrap="square" lIns="50800" rIns="50800" tIns="25400" bIns="25400"/>
-          <a:lstStyle/>
-          <a:p>
-            <a:pPr algn="ctr"/>
-            <a:r>
-              <a:rPr sz="950" b="0">
-                <a:solidFill>
-                  <a:srgbClr val="1F2A3A"/>
-                </a:solidFill>
-                <a:latin typeface="微软雅黑"/>
-                <a:ea typeface="微软雅黑"/>
-              </a:rPr>
-              <a:t>预置领域
-专家库</a:t>
-            </a:r>
-          </a:p>
-        </p:txBody>
-      </p:sp>
-      <p:sp>
-        <p:nvSpPr>
-          <p:cNvPr id="12" name="Rounded Rectangle 11"/>
-          <p:cNvSpPr/>
-          <p:nvPr/>
-        </p:nvSpPr>
-        <p:spPr>
-          <a:xfrm>
-            <a:off x="2416302" y="2057400"/>
-            <a:ext cx="1053846" cy="621792"/>
-          </a:xfrm>
-          <a:prstGeom prst="roundRect">
-            <a:avLst>
-              <a:gd name="adj" fmla="val 16000"/>
-            </a:avLst>
-          </a:prstGeom>
-          <a:solidFill>
-            <a:srgbClr val="FFFFFF"/>
-          </a:solidFill>
-          <a:ln w="12700">
-            <a:solidFill>
-              <a:srgbClr val="2C5F9E"/>
-            </a:solidFill>
-          </a:ln>
-          <a:effectLst/>
-        </p:spPr>
-        <p:style>
-          <a:lnRef idx="1">
-            <a:schemeClr val="accent1"/>
-          </a:lnRef>
-          <a:fillRef idx="3">
-            <a:schemeClr val="accent1"/>
-          </a:fillRef>
-          <a:effectRef idx="2">
-            <a:schemeClr val="accent1"/>
-          </a:effectRef>
-          <a:fontRef idx="minor">
-            <a:schemeClr val="lt1"/>
-          </a:fontRef>
-        </p:style>
-        <p:txBody>
-          <a:bodyPr rtlCol="0" anchor="ctr" wrap="square" lIns="50800" rIns="50800" tIns="25400" bIns="25400"/>
-          <a:lstStyle/>
-          <a:p>
-            <a:pPr algn="ctr"/>
-            <a:r>
-              <a:rPr sz="950" b="0">
-                <a:solidFill>
-                  <a:srgbClr val="1F2A3A"/>
-                </a:solidFill>
-                <a:latin typeface="微软雅黑"/>
-                <a:ea typeface="微软雅黑"/>
-              </a:rPr>
-              <a:t>场景化专家
-团模板</a:t>
-            </a:r>
-          </a:p>
-        </p:txBody>
-      </p:sp>
-      <p:sp>
-        <p:nvSpPr>
-          <p:cNvPr id="13" name="Rounded Rectangle 12"/>
-          <p:cNvSpPr/>
-          <p:nvPr/>
-        </p:nvSpPr>
-        <p:spPr>
-          <a:xfrm>
-            <a:off x="3525012" y="2057400"/>
-            <a:ext cx="1053846" cy="621792"/>
-          </a:xfrm>
-          <a:prstGeom prst="roundRect">
-            <a:avLst>
-              <a:gd name="adj" fmla="val 16000"/>
-            </a:avLst>
-          </a:prstGeom>
-          <a:solidFill>
-            <a:srgbClr val="FFFFFF"/>
-          </a:solidFill>
-          <a:ln w="12700">
-            <a:solidFill>
-              <a:srgbClr val="2C5F9E"/>
-            </a:solidFill>
-          </a:ln>
-          <a:effectLst/>
-        </p:spPr>
-        <p:style>
-          <a:lnRef idx="1">
-            <a:schemeClr val="accent1"/>
-          </a:lnRef>
-          <a:fillRef idx="3">
-            <a:schemeClr val="accent1"/>
-          </a:fillRef>
-          <a:effectRef idx="2">
-            <a:schemeClr val="accent1"/>
-          </a:effectRef>
-          <a:fontRef idx="minor">
-            <a:schemeClr val="lt1"/>
-          </a:fontRef>
-        </p:style>
-        <p:txBody>
-          <a:bodyPr rtlCol="0" anchor="ctr" wrap="square" lIns="50800" rIns="50800" tIns="25400" bIns="25400"/>
-          <a:lstStyle/>
-          <a:p>
-            <a:pPr algn="ctr"/>
-            <a:r>
-              <a:rPr sz="950" b="0">
-                <a:solidFill>
-                  <a:srgbClr val="1F2A3A"/>
-                </a:solidFill>
-                <a:latin typeface="微软雅黑"/>
-                <a:ea typeface="微软雅黑"/>
-              </a:rPr>
-              <a:t>企业专家
-工厂</a:t>
-            </a:r>
-          </a:p>
-        </p:txBody>
-      </p:sp>
-      <p:sp>
-        <p:nvSpPr>
-          <p:cNvPr id="14" name="Rounded Rectangle 13"/>
-          <p:cNvSpPr/>
-          <p:nvPr/>
-        </p:nvSpPr>
-        <p:spPr>
-          <a:xfrm>
-            <a:off x="4633722" y="2057400"/>
-            <a:ext cx="1053846" cy="621792"/>
-          </a:xfrm>
-          <a:prstGeom prst="roundRect">
-            <a:avLst>
-              <a:gd name="adj" fmla="val 16000"/>
-            </a:avLst>
-          </a:prstGeom>
-          <a:solidFill>
-            <a:srgbClr val="FFFFFF"/>
-          </a:solidFill>
-          <a:ln w="12700">
-            <a:solidFill>
-              <a:srgbClr val="2C5F9E"/>
-            </a:solidFill>
-          </a:ln>
-          <a:effectLst/>
-        </p:spPr>
-        <p:style>
-          <a:lnRef idx="1">
-            <a:schemeClr val="accent1"/>
-          </a:lnRef>
-          <a:fillRef idx="3">
-            <a:schemeClr val="accent1"/>
-          </a:fillRef>
-          <a:effectRef idx="2">
-            <a:schemeClr val="accent1"/>
-          </a:effectRef>
-          <a:fontRef idx="minor">
-            <a:schemeClr val="lt1"/>
-          </a:fontRef>
-        </p:style>
-        <p:txBody>
-          <a:bodyPr rtlCol="0" anchor="ctr" wrap="square" lIns="50800" rIns="50800" tIns="25400" bIns="25400"/>
-          <a:lstStyle/>
-          <a:p>
-            <a:pPr algn="ctr"/>
-            <a:r>
-              <a:rPr sz="950" b="0">
-                <a:solidFill>
-                  <a:srgbClr val="1F2A3A"/>
-                </a:solidFill>
-                <a:latin typeface="微软雅黑"/>
-                <a:ea typeface="微软雅黑"/>
-              </a:rPr>
-              <a:t>专家/技能
-市场</a:t>
-            </a:r>
-          </a:p>
-        </p:txBody>
-      </p:sp>
-      <p:sp>
-        <p:nvSpPr>
-          <p:cNvPr id="15" name="Rounded Rectangle 14"/>
-          <p:cNvSpPr/>
-          <p:nvPr/>
-        </p:nvSpPr>
-        <p:spPr>
-          <a:xfrm>
-            <a:off x="320040" y="2779776"/>
-            <a:ext cx="841248" cy="932688"/>
-          </a:xfrm>
-          <a:prstGeom prst="roundRect">
-            <a:avLst>
-              <a:gd name="adj" fmla="val 8000"/>
-            </a:avLst>
           </a:prstGeom>
           <a:solidFill>
             <a:srgbClr val="C7000B"/>
@@ -3767,46 +3437,167 @@
           </a:fontRef>
         </p:style>
         <p:txBody>
-          <a:bodyPr rtlCol="0" anchor="ctr" wrap="square" lIns="50800" rIns="50800" tIns="25400" bIns="25400"/>
+          <a:bodyPr rtlCol="0" anchor="ctr" wrap="square" lIns="25400" rIns="25400" tIns="12700" bIns="12700"/>
           <a:lstStyle/>
           <a:p>
             <a:pPr algn="ctr"/>
             <a:r>
-              <a:rPr sz="1150" b="1">
+              <a:rPr sz="1000" b="1">
                 <a:solidFill>
                   <a:srgbClr val="FFFFFF"/>
                 </a:solidFill>
                 <a:latin typeface="微软雅黑"/>
                 <a:ea typeface="微软雅黑"/>
               </a:rPr>
-              <a:t>调度层</a:t>
-            </a:r>
-          </a:p>
-        </p:txBody>
-      </p:sp>
-      <p:sp>
-        <p:nvSpPr>
-          <p:cNvPr id="16" name="Rounded Rectangle 15"/>
+              <a:t>复杂度评估</a:t>
+            </a:r>
+          </a:p>
+          <a:p>
+            <a:pPr algn="ctr"/>
+            <a:r>
+              <a:rPr sz="1000" b="1">
+                <a:solidFill>
+                  <a:srgbClr val="FFFFFF"/>
+                </a:solidFill>
+                <a:latin typeface="微软雅黑"/>
+                <a:ea typeface="微软雅黑"/>
+              </a:rPr>
+              <a:t>自动路由</a:t>
+            </a:r>
+          </a:p>
+        </p:txBody>
+      </p:sp>
+      <p:cxnSp>
+        <p:nvCxnSpPr>
+          <p:cNvPr id="10" name="Connector 9"/>
+          <p:cNvCxnSpPr/>
+          <p:nvPr/>
+        </p:nvCxnSpPr>
+        <p:spPr>
+          <a:xfrm>
+            <a:off x="3063240" y="1810512"/>
+            <a:ext cx="0" cy="182880"/>
+          </a:xfrm>
+          <a:prstGeom prst="line">
+            <a:avLst/>
+          </a:prstGeom>
+          <a:ln w="19050">
+            <a:solidFill>
+              <a:srgbClr val="1F2A3A"/>
+            </a:solidFill>
+            <a:tailEnd type="triangle" w="med" len="med"/>
+          </a:ln>
+          <a:effectLst/>
+        </p:spPr>
+        <p:style>
+          <a:lnRef idx="2">
+            <a:schemeClr val="accent1"/>
+          </a:lnRef>
+          <a:fillRef idx="0">
+            <a:schemeClr val="accent1"/>
+          </a:fillRef>
+          <a:effectRef idx="1">
+            <a:schemeClr val="accent1"/>
+          </a:effectRef>
+          <a:fontRef idx="minor">
+            <a:schemeClr val="tx1"/>
+          </a:fontRef>
+        </p:style>
+      </p:cxnSp>
+      <p:cxnSp>
+        <p:nvCxnSpPr>
+          <p:cNvPr id="11" name="Connector 10"/>
+          <p:cNvCxnSpPr/>
+          <p:nvPr/>
+        </p:nvCxnSpPr>
+        <p:spPr>
+          <a:xfrm flipH="1">
+            <a:off x="1143000" y="2395728"/>
+            <a:ext cx="1097280" cy="621792"/>
+          </a:xfrm>
+          <a:prstGeom prst="line">
+            <a:avLst/>
+          </a:prstGeom>
+          <a:ln w="19050">
+            <a:solidFill>
+              <a:srgbClr val="5A6472"/>
+            </a:solidFill>
+            <a:tailEnd type="triangle" w="med" len="med"/>
+          </a:ln>
+          <a:effectLst/>
+        </p:spPr>
+        <p:style>
+          <a:lnRef idx="2">
+            <a:schemeClr val="accent1"/>
+          </a:lnRef>
+          <a:fillRef idx="0">
+            <a:schemeClr val="accent1"/>
+          </a:fillRef>
+          <a:effectRef idx="1">
+            <a:schemeClr val="accent1"/>
+          </a:effectRef>
+          <a:fontRef idx="minor">
+            <a:schemeClr val="tx1"/>
+          </a:fontRef>
+        </p:style>
+      </p:cxnSp>
+      <p:sp>
+        <p:nvSpPr>
+          <p:cNvPr id="12" name="TextBox 11"/>
+          <p:cNvSpPr txBox="1"/>
+          <p:nvPr/>
+        </p:nvSpPr>
+        <p:spPr>
+          <a:xfrm>
+            <a:off x="749808" y="2432304"/>
+            <a:ext cx="914400" cy="228600"/>
+          </a:xfrm>
+          <a:prstGeom prst="rect">
+            <a:avLst/>
+          </a:prstGeom>
+          <a:noFill/>
+        </p:spPr>
+        <p:txBody>
+          <a:bodyPr wrap="square" anchor="ctr" lIns="25400" rIns="25400" tIns="12700" bIns="12700">
+            <a:spAutoFit/>
+          </a:bodyPr>
+          <a:lstStyle/>
+          <a:p>
+            <a:pPr algn="ctr"/>
+            <a:r>
+              <a:rPr sz="850" b="0">
+                <a:solidFill>
+                  <a:srgbClr val="5A6472"/>
+                </a:solidFill>
+                <a:latin typeface="微软雅黑"/>
+                <a:ea typeface="微软雅黑"/>
+              </a:rPr>
+              <a:t>简单任务</a:t>
+            </a:r>
+          </a:p>
+        </p:txBody>
+      </p:sp>
+      <p:sp>
+        <p:nvSpPr>
+          <p:cNvPr id="13" name="Rounded Rectangle 12"/>
           <p:cNvSpPr/>
           <p:nvPr/>
         </p:nvSpPr>
         <p:spPr>
           <a:xfrm>
-            <a:off x="1234440" y="2779776"/>
-            <a:ext cx="4526280" cy="932688"/>
+            <a:off x="502920" y="3017520"/>
+            <a:ext cx="1188720" cy="548640"/>
           </a:xfrm>
           <a:prstGeom prst="roundRect">
             <a:avLst>
-              <a:gd name="adj" fmla="val 8000"/>
+              <a:gd name="adj" fmla="val 12000"/>
             </a:avLst>
           </a:prstGeom>
           <a:solidFill>
-            <a:srgbClr val="F2F5F9"/>
+            <a:srgbClr val="4A5568"/>
           </a:solidFill>
-          <a:ln w="12700">
-            <a:solidFill>
-              <a:srgbClr val="C7000B"/>
-            </a:solidFill>
+          <a:ln>
+            <a:noFill/>
           </a:ln>
           <a:effectLst/>
         </p:spPr>
@@ -3825,23 +3616,83 @@
           </a:fontRef>
         </p:style>
         <p:txBody>
-          <a:bodyPr rtlCol="0" anchor="ctr"/>
+          <a:bodyPr rtlCol="0" anchor="ctr" wrap="square" lIns="25400" rIns="25400" tIns="12700" bIns="12700"/>
           <a:lstStyle/>
           <a:p>
             <a:pPr algn="ctr"/>
-          </a:p>
-        </p:txBody>
-      </p:sp>
-      <p:sp>
-        <p:nvSpPr>
-          <p:cNvPr id="17" name="TextBox 16"/>
+            <a:r>
+              <a:rPr sz="1050" b="1">
+                <a:solidFill>
+                  <a:srgbClr val="FFFFFF"/>
+                </a:solidFill>
+                <a:latin typeface="微软雅黑"/>
+                <a:ea typeface="微软雅黑"/>
+              </a:rPr>
+              <a:t>单 Agent</a:t>
+            </a:r>
+          </a:p>
+          <a:p>
+            <a:pPr algn="ctr"/>
+            <a:r>
+              <a:rPr sz="850" b="0">
+                <a:solidFill>
+                  <a:srgbClr val="FFFFFF"/>
+                </a:solidFill>
+                <a:latin typeface="微软雅黑"/>
+                <a:ea typeface="微软雅黑"/>
+              </a:rPr>
+              <a:t>直接执行</a:t>
+            </a:r>
+          </a:p>
+        </p:txBody>
+      </p:sp>
+      <p:cxnSp>
+        <p:nvCxnSpPr>
+          <p:cNvPr id="14" name="Connector 13"/>
+          <p:cNvCxnSpPr/>
+          <p:nvPr/>
+        </p:nvCxnSpPr>
+        <p:spPr>
+          <a:xfrm>
+            <a:off x="3886200" y="2395728"/>
+            <a:ext cx="155448" cy="530352"/>
+          </a:xfrm>
+          <a:prstGeom prst="line">
+            <a:avLst/>
+          </a:prstGeom>
+          <a:ln w="19050">
+            <a:solidFill>
+              <a:srgbClr val="5A6472"/>
+            </a:solidFill>
+            <a:tailEnd type="triangle" w="med" len="med"/>
+          </a:ln>
+          <a:effectLst/>
+        </p:spPr>
+        <p:style>
+          <a:lnRef idx="2">
+            <a:schemeClr val="accent1"/>
+          </a:lnRef>
+          <a:fillRef idx="0">
+            <a:schemeClr val="accent1"/>
+          </a:fillRef>
+          <a:effectRef idx="1">
+            <a:schemeClr val="accent1"/>
+          </a:effectRef>
+          <a:fontRef idx="minor">
+            <a:schemeClr val="tx1"/>
+          </a:fontRef>
+        </p:style>
+      </p:cxnSp>
+      <p:sp>
+        <p:nvSpPr>
+          <p:cNvPr id="15" name="TextBox 14"/>
           <p:cNvSpPr txBox="1"/>
           <p:nvPr/>
         </p:nvSpPr>
         <p:spPr>
           <a:xfrm>
-            <a:off x="1307592" y="2798064"/>
-            <a:ext cx="4379976" cy="237744"/>
+            <a:off x="4041648" y="2377440"/>
+            <a:ext cx="914400" cy="228600"/>
           </a:xfrm>
           <a:prstGeom prst="rect">
             <a:avLst/>
@@ -3849,47 +3700,47 @@
           <a:noFill/>
         </p:spPr>
         <p:txBody>
-          <a:bodyPr wrap="square" anchor="ctr" lIns="50800" rIns="50800" tIns="25400" bIns="25400">
+          <a:bodyPr wrap="square" anchor="ctr" lIns="25400" rIns="25400" tIns="12700" bIns="12700">
             <a:spAutoFit/>
           </a:bodyPr>
           <a:lstStyle/>
           <a:p>
-            <a:pPr algn="l"/>
-            <a:r>
-              <a:rPr sz="1100" b="1">
+            <a:pPr algn="ctr"/>
+            <a:r>
+              <a:rPr sz="850" b="0">
                 <a:solidFill>
-                  <a:srgbClr val="C7000B"/>
+                  <a:srgbClr val="5A6472"/>
                 </a:solidFill>
                 <a:latin typeface="微软雅黑"/>
                 <a:ea typeface="微软雅黑"/>
               </a:rPr>
-              <a:t>复杂度自适应路由(差异化主打:业界尚无显式产品化)</a:t>
-            </a:r>
-          </a:p>
-        </p:txBody>
-      </p:sp>
-      <p:sp>
-        <p:nvSpPr>
-          <p:cNvPr id="18" name="Rounded Rectangle 17"/>
+              <a:t>复杂任务</a:t>
+            </a:r>
+          </a:p>
+        </p:txBody>
+      </p:sp>
+      <p:sp>
+        <p:nvSpPr>
+          <p:cNvPr id="16" name="Rounded Rectangle 15"/>
           <p:cNvSpPr/>
           <p:nvPr/>
         </p:nvSpPr>
         <p:spPr>
           <a:xfrm>
-            <a:off x="1307592" y="3054096"/>
-            <a:ext cx="1053846" cy="621792"/>
+            <a:off x="2377440" y="2926080"/>
+            <a:ext cx="3310128" cy="1691640"/>
           </a:xfrm>
           <a:prstGeom prst="roundRect">
             <a:avLst>
-              <a:gd name="adj" fmla="val 16000"/>
+              <a:gd name="adj" fmla="val 12000"/>
             </a:avLst>
           </a:prstGeom>
           <a:solidFill>
-            <a:srgbClr val="FFFFFF"/>
+            <a:srgbClr val="EEF6F4"/>
           </a:solidFill>
-          <a:ln w="12700">
+          <a:ln w="15240">
             <a:solidFill>
-              <a:srgbClr val="C7000B"/>
+              <a:srgbClr val="1F7A6D"/>
             </a:solidFill>
           </a:ln>
           <a:effectLst/>
@@ -3909,215 +3760,63 @@
           </a:fontRef>
         </p:style>
         <p:txBody>
-          <a:bodyPr rtlCol="0" anchor="ctr" wrap="square" lIns="50800" rIns="50800" tIns="25400" bIns="25400"/>
+          <a:bodyPr rtlCol="0" anchor="ctr"/>
           <a:lstStyle/>
           <a:p>
             <a:pPr algn="ctr"/>
-            <a:r>
-              <a:rPr sz="950" b="0">
+          </a:p>
+        </p:txBody>
+      </p:sp>
+      <p:sp>
+        <p:nvSpPr>
+          <p:cNvPr id="17" name="TextBox 16"/>
+          <p:cNvSpPr txBox="1"/>
+          <p:nvPr/>
+        </p:nvSpPr>
+        <p:spPr>
+          <a:xfrm>
+            <a:off x="2487168" y="2980944"/>
+            <a:ext cx="2194560" cy="228600"/>
+          </a:xfrm>
+          <a:prstGeom prst="rect">
+            <a:avLst/>
+          </a:prstGeom>
+          <a:noFill/>
+        </p:spPr>
+        <p:txBody>
+          <a:bodyPr wrap="square" anchor="ctr" lIns="25400" rIns="25400" tIns="12700" bIns="12700">
+            <a:spAutoFit/>
+          </a:bodyPr>
+          <a:lstStyle/>
+          <a:p>
+            <a:pPr algn="l"/>
+            <a:r>
+              <a:rPr sz="950" b="1">
                 <a:solidFill>
-                  <a:srgbClr val="1F2A3A"/>
+                  <a:srgbClr val="1F7A6D"/>
                 </a:solidFill>
                 <a:latin typeface="微软雅黑"/>
                 <a:ea typeface="微软雅黑"/>
               </a:rPr>
-              <a:t>任务复杂度
-评估器</a:t>
-            </a:r>
-          </a:p>
-        </p:txBody>
-      </p:sp>
-      <p:sp>
-        <p:nvSpPr>
-          <p:cNvPr id="19" name="Rounded Rectangle 18"/>
+              <a:t>Agent Team · 自主编排</a:t>
+            </a:r>
+          </a:p>
+        </p:txBody>
+      </p:sp>
+      <p:sp>
+        <p:nvSpPr>
+          <p:cNvPr id="18" name="Rounded Rectangle 17"/>
           <p:cNvSpPr/>
           <p:nvPr/>
         </p:nvSpPr>
         <p:spPr>
           <a:xfrm>
-            <a:off x="2416302" y="3054096"/>
-            <a:ext cx="1053846" cy="621792"/>
+            <a:off x="3346704" y="3218688"/>
+            <a:ext cx="1371600" cy="411480"/>
           </a:xfrm>
           <a:prstGeom prst="roundRect">
             <a:avLst>
-              <a:gd name="adj" fmla="val 16000"/>
-            </a:avLst>
-          </a:prstGeom>
-          <a:solidFill>
-            <a:srgbClr val="FFFFFF"/>
-          </a:solidFill>
-          <a:ln w="12700">
-            <a:solidFill>
-              <a:srgbClr val="C7000B"/>
-            </a:solidFill>
-          </a:ln>
-          <a:effectLst/>
-        </p:spPr>
-        <p:style>
-          <a:lnRef idx="1">
-            <a:schemeClr val="accent1"/>
-          </a:lnRef>
-          <a:fillRef idx="3">
-            <a:schemeClr val="accent1"/>
-          </a:fillRef>
-          <a:effectRef idx="2">
-            <a:schemeClr val="accent1"/>
-          </a:effectRef>
-          <a:fontRef idx="minor">
-            <a:schemeClr val="lt1"/>
-          </a:fontRef>
-        </p:style>
-        <p:txBody>
-          <a:bodyPr rtlCol="0" anchor="ctr" wrap="square" lIns="50800" rIns="50800" tIns="25400" bIns="25400"/>
-          <a:lstStyle/>
-          <a:p>
-            <a:pPr algn="ctr"/>
-            <a:r>
-              <a:rPr sz="950" b="0">
-                <a:solidFill>
-                  <a:srgbClr val="1F2A3A"/>
-                </a:solidFill>
-                <a:latin typeface="微软雅黑"/>
-                <a:ea typeface="微软雅黑"/>
-              </a:rPr>
-              <a:t>三档执行
-模式决策</a:t>
-            </a:r>
-          </a:p>
-        </p:txBody>
-      </p:sp>
-      <p:sp>
-        <p:nvSpPr>
-          <p:cNvPr id="20" name="Rounded Rectangle 19"/>
-          <p:cNvSpPr/>
-          <p:nvPr/>
-        </p:nvSpPr>
-        <p:spPr>
-          <a:xfrm>
-            <a:off x="3525012" y="3054096"/>
-            <a:ext cx="1053846" cy="621792"/>
-          </a:xfrm>
-          <a:prstGeom prst="roundRect">
-            <a:avLst>
-              <a:gd name="adj" fmla="val 16000"/>
-            </a:avLst>
-          </a:prstGeom>
-          <a:solidFill>
-            <a:srgbClr val="FFFFFF"/>
-          </a:solidFill>
-          <a:ln w="12700">
-            <a:solidFill>
-              <a:srgbClr val="C7000B"/>
-            </a:solidFill>
-          </a:ln>
-          <a:effectLst/>
-        </p:spPr>
-        <p:style>
-          <a:lnRef idx="1">
-            <a:schemeClr val="accent1"/>
-          </a:lnRef>
-          <a:fillRef idx="3">
-            <a:schemeClr val="accent1"/>
-          </a:fillRef>
-          <a:effectRef idx="2">
-            <a:schemeClr val="accent1"/>
-          </a:effectRef>
-          <a:fontRef idx="minor">
-            <a:schemeClr val="lt1"/>
-          </a:fontRef>
-        </p:style>
-        <p:txBody>
-          <a:bodyPr rtlCol="0" anchor="ctr" wrap="square" lIns="50800" rIns="50800" tIns="25400" bIns="25400"/>
-          <a:lstStyle/>
-          <a:p>
-            <a:pPr algn="ctr"/>
-            <a:r>
-              <a:rPr sz="950" b="0">
-                <a:solidFill>
-                  <a:srgbClr val="1F2A3A"/>
-                </a:solidFill>
-                <a:latin typeface="微软雅黑"/>
-                <a:ea typeface="微软雅黑"/>
-              </a:rPr>
-              <a:t>运行中动态
-升降级</a:t>
-            </a:r>
-          </a:p>
-        </p:txBody>
-      </p:sp>
-      <p:sp>
-        <p:nvSpPr>
-          <p:cNvPr id="21" name="Rounded Rectangle 20"/>
-          <p:cNvSpPr/>
-          <p:nvPr/>
-        </p:nvSpPr>
-        <p:spPr>
-          <a:xfrm>
-            <a:off x="4633722" y="3054096"/>
-            <a:ext cx="1053846" cy="621792"/>
-          </a:xfrm>
-          <a:prstGeom prst="roundRect">
-            <a:avLst>
-              <a:gd name="adj" fmla="val 16000"/>
-            </a:avLst>
-          </a:prstGeom>
-          <a:solidFill>
-            <a:srgbClr val="FFFFFF"/>
-          </a:solidFill>
-          <a:ln w="12700">
-            <a:solidFill>
-              <a:srgbClr val="C7000B"/>
-            </a:solidFill>
-          </a:ln>
-          <a:effectLst/>
-        </p:spPr>
-        <p:style>
-          <a:lnRef idx="1">
-            <a:schemeClr val="accent1"/>
-          </a:lnRef>
-          <a:fillRef idx="3">
-            <a:schemeClr val="accent1"/>
-          </a:fillRef>
-          <a:effectRef idx="2">
-            <a:schemeClr val="accent1"/>
-          </a:effectRef>
-          <a:fontRef idx="minor">
-            <a:schemeClr val="lt1"/>
-          </a:fontRef>
-        </p:style>
-        <p:txBody>
-          <a:bodyPr rtlCol="0" anchor="ctr" wrap="square" lIns="50800" rIns="50800" tIns="25400" bIns="25400"/>
-          <a:lstStyle/>
-          <a:p>
-            <a:pPr algn="ctr"/>
-            <a:r>
-              <a:rPr sz="950" b="0">
-                <a:solidFill>
-                  <a:srgbClr val="1F2A3A"/>
-                </a:solidFill>
-                <a:latin typeface="微软雅黑"/>
-                <a:ea typeface="微软雅黑"/>
-              </a:rPr>
-              <a:t>成本-质量
-策略路由</a:t>
-            </a:r>
-          </a:p>
-        </p:txBody>
-      </p:sp>
-      <p:sp>
-        <p:nvSpPr>
-          <p:cNvPr id="22" name="Rounded Rectangle 21"/>
-          <p:cNvSpPr/>
-          <p:nvPr/>
-        </p:nvSpPr>
-        <p:spPr>
-          <a:xfrm>
-            <a:off x="320040" y="3776472"/>
-            <a:ext cx="841248" cy="932688"/>
-          </a:xfrm>
-          <a:prstGeom prst="roundRect">
-            <a:avLst>
-              <a:gd name="adj" fmla="val 8000"/>
+              <a:gd name="adj" fmla="val 12000"/>
             </a:avLst>
           </a:prstGeom>
           <a:solidFill>
@@ -4143,121 +3842,37 @@
           </a:fontRef>
         </p:style>
         <p:txBody>
-          <a:bodyPr rtlCol="0" anchor="ctr" wrap="square" lIns="50800" rIns="50800" tIns="25400" bIns="25400"/>
+          <a:bodyPr rtlCol="0" anchor="ctr" wrap="square" lIns="25400" rIns="25400" tIns="12700" bIns="12700"/>
           <a:lstStyle/>
           <a:p>
             <a:pPr algn="ctr"/>
             <a:r>
-              <a:rPr sz="1150" b="1">
+              <a:rPr sz="850" b="1">
                 <a:solidFill>
                   <a:srgbClr val="FFFFFF"/>
                 </a:solidFill>
                 <a:latin typeface="微软雅黑"/>
                 <a:ea typeface="微软雅黑"/>
               </a:rPr>
-              <a:t>编排层</a:t>
-            </a:r>
-          </a:p>
-        </p:txBody>
-      </p:sp>
-      <p:sp>
-        <p:nvSpPr>
-          <p:cNvPr id="23" name="Rounded Rectangle 22"/>
+              <a:t>Team Lead:递归拆解·组队</a:t>
+            </a:r>
+          </a:p>
+        </p:txBody>
+      </p:sp>
+      <p:sp>
+        <p:nvSpPr>
+          <p:cNvPr id="19" name="Rounded Rectangle 18"/>
           <p:cNvSpPr/>
           <p:nvPr/>
         </p:nvSpPr>
         <p:spPr>
           <a:xfrm>
-            <a:off x="1234440" y="3776472"/>
-            <a:ext cx="4526280" cy="932688"/>
+            <a:off x="2542032" y="3858768"/>
+            <a:ext cx="932688" cy="384048"/>
           </a:xfrm>
           <a:prstGeom prst="roundRect">
             <a:avLst>
-              <a:gd name="adj" fmla="val 8000"/>
-            </a:avLst>
-          </a:prstGeom>
-          <a:solidFill>
-            <a:srgbClr val="F2F5F9"/>
-          </a:solidFill>
-          <a:ln w="12700">
-            <a:solidFill>
-              <a:srgbClr val="1F7A6D"/>
-            </a:solidFill>
-          </a:ln>
-          <a:effectLst/>
-        </p:spPr>
-        <p:style>
-          <a:lnRef idx="1">
-            <a:schemeClr val="accent1"/>
-          </a:lnRef>
-          <a:fillRef idx="3">
-            <a:schemeClr val="accent1"/>
-          </a:fillRef>
-          <a:effectRef idx="2">
-            <a:schemeClr val="accent1"/>
-          </a:effectRef>
-          <a:fontRef idx="minor">
-            <a:schemeClr val="lt1"/>
-          </a:fontRef>
-        </p:style>
-        <p:txBody>
-          <a:bodyPr rtlCol="0" anchor="ctr"/>
-          <a:lstStyle/>
-          <a:p>
-            <a:pPr algn="ctr"/>
-          </a:p>
-        </p:txBody>
-      </p:sp>
-      <p:sp>
-        <p:nvSpPr>
-          <p:cNvPr id="24" name="TextBox 23"/>
-          <p:cNvSpPr txBox="1"/>
-          <p:nvPr/>
-        </p:nvSpPr>
-        <p:spPr>
-          <a:xfrm>
-            <a:off x="1307592" y="3794759"/>
-            <a:ext cx="4379976" cy="237744"/>
-          </a:xfrm>
-          <a:prstGeom prst="rect">
-            <a:avLst/>
-          </a:prstGeom>
-          <a:noFill/>
-        </p:spPr>
-        <p:txBody>
-          <a:bodyPr wrap="square" anchor="ctr" lIns="50800" rIns="50800" tIns="25400" bIns="25400">
-            <a:spAutoFit/>
-          </a:bodyPr>
-          <a:lstStyle/>
-          <a:p>
-            <a:pPr algn="l"/>
-            <a:r>
-              <a:rPr sz="1100" b="1">
-                <a:solidFill>
-                  <a:srgbClr val="1F7A6D"/>
-                </a:solidFill>
-                <a:latin typeface="微软雅黑"/>
-                <a:ea typeface="微软雅黑"/>
-              </a:rPr>
-              <a:t>自主编排与固化(确定性、可复用)</a:t>
-            </a:r>
-          </a:p>
-        </p:txBody>
-      </p:sp>
-      <p:sp>
-        <p:nvSpPr>
-          <p:cNvPr id="25" name="Rounded Rectangle 24"/>
-          <p:cNvSpPr/>
-          <p:nvPr/>
-        </p:nvSpPr>
-        <p:spPr>
-          <a:xfrm>
-            <a:off x="1307592" y="4050791"/>
-            <a:ext cx="1053846" cy="621792"/>
-          </a:xfrm>
-          <a:prstGeom prst="roundRect">
-            <a:avLst>
-              <a:gd name="adj" fmla="val 16000"/>
+              <a:gd name="adj" fmla="val 12000"/>
             </a:avLst>
           </a:prstGeom>
           <a:solidFill>
@@ -4285,38 +3900,74 @@
           </a:fontRef>
         </p:style>
         <p:txBody>
-          <a:bodyPr rtlCol="0" anchor="ctr" wrap="square" lIns="50800" rIns="50800" tIns="25400" bIns="25400"/>
+          <a:bodyPr rtlCol="0" anchor="ctr" wrap="square" lIns="25400" rIns="25400" tIns="12700" bIns="12700"/>
           <a:lstStyle/>
           <a:p>
             <a:pPr algn="ctr"/>
             <a:r>
-              <a:rPr sz="950" b="0">
+              <a:rPr sz="900" b="0">
                 <a:solidFill>
                   <a:srgbClr val="1F2A3A"/>
                 </a:solidFill>
                 <a:latin typeface="微软雅黑"/>
                 <a:ea typeface="微软雅黑"/>
               </a:rPr>
-              <a:t>递归Planner
-任务拆解</a:t>
-            </a:r>
-          </a:p>
-        </p:txBody>
-      </p:sp>
-      <p:sp>
-        <p:nvSpPr>
-          <p:cNvPr id="26" name="Rounded Rectangle 25"/>
+              <a:t>开发专家</a:t>
+            </a:r>
+          </a:p>
+        </p:txBody>
+      </p:sp>
+      <p:cxnSp>
+        <p:nvCxnSpPr>
+          <p:cNvPr id="20" name="Connector 19"/>
+          <p:cNvCxnSpPr/>
+          <p:nvPr/>
+        </p:nvCxnSpPr>
+        <p:spPr>
+          <a:xfrm flipH="1">
+            <a:off x="3008376" y="3630168"/>
+            <a:ext cx="1024128" cy="228600"/>
+          </a:xfrm>
+          <a:prstGeom prst="line">
+            <a:avLst/>
+          </a:prstGeom>
+          <a:ln w="15240">
+            <a:solidFill>
+              <a:srgbClr val="1F7A6D"/>
+            </a:solidFill>
+            <a:tailEnd type="triangle" w="med" len="med"/>
+          </a:ln>
+          <a:effectLst/>
+        </p:spPr>
+        <p:style>
+          <a:lnRef idx="2">
+            <a:schemeClr val="accent1"/>
+          </a:lnRef>
+          <a:fillRef idx="0">
+            <a:schemeClr val="accent1"/>
+          </a:fillRef>
+          <a:effectRef idx="1">
+            <a:schemeClr val="accent1"/>
+          </a:effectRef>
+          <a:fontRef idx="minor">
+            <a:schemeClr val="tx1"/>
+          </a:fontRef>
+        </p:style>
+      </p:cxnSp>
+      <p:sp>
+        <p:nvSpPr>
+          <p:cNvPr id="21" name="Rounded Rectangle 20"/>
           <p:cNvSpPr/>
           <p:nvPr/>
         </p:nvSpPr>
         <p:spPr>
           <a:xfrm>
-            <a:off x="2416302" y="4050791"/>
-            <a:ext cx="1053846" cy="621792"/>
+            <a:off x="3593592" y="3858768"/>
+            <a:ext cx="932688" cy="384048"/>
           </a:xfrm>
           <a:prstGeom prst="roundRect">
             <a:avLst>
-              <a:gd name="adj" fmla="val 16000"/>
+              <a:gd name="adj" fmla="val 12000"/>
             </a:avLst>
           </a:prstGeom>
           <a:solidFill>
@@ -4344,38 +3995,74 @@
           </a:fontRef>
         </p:style>
         <p:txBody>
-          <a:bodyPr rtlCol="0" anchor="ctr" wrap="square" lIns="50800" rIns="50800" tIns="25400" bIns="25400"/>
+          <a:bodyPr rtlCol="0" anchor="ctr" wrap="square" lIns="25400" rIns="25400" tIns="12700" bIns="12700"/>
           <a:lstStyle/>
           <a:p>
             <a:pPr algn="ctr"/>
             <a:r>
-              <a:rPr sz="950" b="0">
+              <a:rPr sz="900" b="0">
                 <a:solidFill>
                   <a:srgbClr val="1F2A3A"/>
                 </a:solidFill>
                 <a:latin typeface="微软雅黑"/>
                 <a:ea typeface="微软雅黑"/>
               </a:rPr>
-              <a:t>Teammate
-动态合成</a:t>
-            </a:r>
-          </a:p>
-        </p:txBody>
-      </p:sp>
-      <p:sp>
-        <p:nvSpPr>
-          <p:cNvPr id="27" name="Rounded Rectangle 26"/>
+              <a:t>测试专家</a:t>
+            </a:r>
+          </a:p>
+        </p:txBody>
+      </p:sp>
+      <p:cxnSp>
+        <p:nvCxnSpPr>
+          <p:cNvPr id="22" name="Connector 21"/>
+          <p:cNvCxnSpPr/>
+          <p:nvPr/>
+        </p:nvCxnSpPr>
+        <p:spPr>
+          <a:xfrm>
+            <a:off x="4032504" y="3630168"/>
+            <a:ext cx="27432" cy="228600"/>
+          </a:xfrm>
+          <a:prstGeom prst="line">
+            <a:avLst/>
+          </a:prstGeom>
+          <a:ln w="15240">
+            <a:solidFill>
+              <a:srgbClr val="1F7A6D"/>
+            </a:solidFill>
+            <a:tailEnd type="triangle" w="med" len="med"/>
+          </a:ln>
+          <a:effectLst/>
+        </p:spPr>
+        <p:style>
+          <a:lnRef idx="2">
+            <a:schemeClr val="accent1"/>
+          </a:lnRef>
+          <a:fillRef idx="0">
+            <a:schemeClr val="accent1"/>
+          </a:fillRef>
+          <a:effectRef idx="1">
+            <a:schemeClr val="accent1"/>
+          </a:effectRef>
+          <a:fontRef idx="minor">
+            <a:schemeClr val="tx1"/>
+          </a:fontRef>
+        </p:style>
+      </p:cxnSp>
+      <p:sp>
+        <p:nvSpPr>
+          <p:cNvPr id="23" name="Rounded Rectangle 22"/>
           <p:cNvSpPr/>
           <p:nvPr/>
         </p:nvSpPr>
         <p:spPr>
           <a:xfrm>
-            <a:off x="3525012" y="4050791"/>
-            <a:ext cx="1053846" cy="621792"/>
+            <a:off x="4645152" y="3858768"/>
+            <a:ext cx="932688" cy="384048"/>
           </a:xfrm>
           <a:prstGeom prst="roundRect">
             <a:avLst>
-              <a:gd name="adj" fmla="val 16000"/>
+              <a:gd name="adj" fmla="val 12000"/>
             </a:avLst>
           </a:prstGeom>
           <a:solidFill>
@@ -4403,38 +4090,252 @@
           </a:fontRef>
         </p:style>
         <p:txBody>
-          <a:bodyPr rtlCol="0" anchor="ctr" wrap="square" lIns="50800" rIns="50800" tIns="25400" bIns="25400"/>
+          <a:bodyPr rtlCol="0" anchor="ctr" wrap="square" lIns="25400" rIns="25400" tIns="12700" bIns="12700"/>
           <a:lstStyle/>
           <a:p>
             <a:pPr algn="ctr"/>
             <a:r>
-              <a:rPr sz="950" b="0">
+              <a:rPr sz="900" b="0">
                 <a:solidFill>
                   <a:srgbClr val="1F2A3A"/>
                 </a:solidFill>
                 <a:latin typeface="微软雅黑"/>
                 <a:ea typeface="微软雅黑"/>
               </a:rPr>
-              <a:t>团队蓝图
-固化</a:t>
-            </a:r>
-          </a:p>
-        </p:txBody>
-      </p:sp>
-      <p:sp>
-        <p:nvSpPr>
-          <p:cNvPr id="28" name="Rounded Rectangle 27"/>
+              <a:t>安全专家</a:t>
+            </a:r>
+          </a:p>
+        </p:txBody>
+      </p:sp>
+      <p:cxnSp>
+        <p:nvCxnSpPr>
+          <p:cNvPr id="24" name="Connector 23"/>
+          <p:cNvCxnSpPr/>
+          <p:nvPr/>
+        </p:nvCxnSpPr>
+        <p:spPr>
+          <a:xfrm>
+            <a:off x="4032504" y="3630168"/>
+            <a:ext cx="1078992" cy="228600"/>
+          </a:xfrm>
+          <a:prstGeom prst="line">
+            <a:avLst/>
+          </a:prstGeom>
+          <a:ln w="15240">
+            <a:solidFill>
+              <a:srgbClr val="1F7A6D"/>
+            </a:solidFill>
+            <a:tailEnd type="triangle" w="med" len="med"/>
+          </a:ln>
+          <a:effectLst/>
+        </p:spPr>
+        <p:style>
+          <a:lnRef idx="2">
+            <a:schemeClr val="accent1"/>
+          </a:lnRef>
+          <a:fillRef idx="0">
+            <a:schemeClr val="accent1"/>
+          </a:fillRef>
+          <a:effectRef idx="1">
+            <a:schemeClr val="accent1"/>
+          </a:effectRef>
+          <a:fontRef idx="minor">
+            <a:schemeClr val="tx1"/>
+          </a:fontRef>
+        </p:style>
+      </p:cxnSp>
+      <p:sp>
+        <p:nvSpPr>
+          <p:cNvPr id="25" name="TextBox 24"/>
+          <p:cNvSpPr txBox="1"/>
+          <p:nvPr/>
+        </p:nvSpPr>
+        <p:spPr>
+          <a:xfrm>
+            <a:off x="2468880" y="4315968"/>
+            <a:ext cx="3108960" cy="228600"/>
+          </a:xfrm>
+          <a:prstGeom prst="rect">
+            <a:avLst/>
+          </a:prstGeom>
+          <a:noFill/>
+        </p:spPr>
+        <p:txBody>
+          <a:bodyPr wrap="square" anchor="ctr" lIns="25400" rIns="25400" tIns="12700" bIns="12700">
+            <a:spAutoFit/>
+          </a:bodyPr>
+          <a:lstStyle/>
+          <a:p>
+            <a:pPr algn="ctr"/>
+            <a:r>
+              <a:rPr sz="800" b="0">
+                <a:solidFill>
+                  <a:srgbClr val="5A6472"/>
+                </a:solidFill>
+                <a:latin typeface="微软雅黑"/>
+                <a:ea typeface="微软雅黑"/>
+              </a:rPr>
+              <a:t>共享任务列表 · Teammate 间消息协同</a:t>
+            </a:r>
+          </a:p>
+        </p:txBody>
+      </p:sp>
+      <p:cxnSp>
+        <p:nvCxnSpPr>
+          <p:cNvPr id="26" name="Connector 25"/>
+          <p:cNvCxnSpPr/>
+          <p:nvPr/>
+        </p:nvCxnSpPr>
+        <p:spPr>
+          <a:xfrm>
+            <a:off x="1691640" y="3291840"/>
+            <a:ext cx="685800" cy="0"/>
+          </a:xfrm>
+          <a:prstGeom prst="line">
+            <a:avLst/>
+          </a:prstGeom>
+          <a:ln w="19050">
+            <a:solidFill>
+              <a:srgbClr val="C7000B"/>
+            </a:solidFill>
+            <a:prstDash val="dash"/>
+            <a:headEnd type="triangle" w="med" len="med"/>
+            <a:tailEnd type="triangle" w="med" len="med"/>
+          </a:ln>
+          <a:effectLst/>
+        </p:spPr>
+        <p:style>
+          <a:lnRef idx="2">
+            <a:schemeClr val="accent1"/>
+          </a:lnRef>
+          <a:fillRef idx="0">
+            <a:schemeClr val="accent1"/>
+          </a:fillRef>
+          <a:effectRef idx="1">
+            <a:schemeClr val="accent1"/>
+          </a:effectRef>
+          <a:fontRef idx="minor">
+            <a:schemeClr val="tx1"/>
+          </a:fontRef>
+        </p:style>
+      </p:cxnSp>
+      <p:sp>
+        <p:nvSpPr>
+          <p:cNvPr id="27" name="TextBox 26"/>
+          <p:cNvSpPr txBox="1"/>
+          <p:nvPr/>
+        </p:nvSpPr>
+        <p:spPr>
+          <a:xfrm>
+            <a:off x="1353312" y="2834640"/>
+            <a:ext cx="1463040" cy="228600"/>
+          </a:xfrm>
+          <a:prstGeom prst="rect">
+            <a:avLst/>
+          </a:prstGeom>
+          <a:noFill/>
+        </p:spPr>
+        <p:txBody>
+          <a:bodyPr wrap="square" anchor="ctr" lIns="25400" rIns="25400" tIns="12700" bIns="12700">
+            <a:spAutoFit/>
+          </a:bodyPr>
+          <a:lstStyle/>
+          <a:p>
+            <a:pPr algn="ctr"/>
+            <a:r>
+              <a:rPr sz="850" b="1">
+                <a:solidFill>
+                  <a:srgbClr val="C7000B"/>
+                </a:solidFill>
+                <a:latin typeface="微软雅黑"/>
+                <a:ea typeface="微软雅黑"/>
+              </a:rPr>
+              <a:t>动态升降级</a:t>
+            </a:r>
+          </a:p>
+        </p:txBody>
+      </p:sp>
+      <p:sp>
+        <p:nvSpPr>
+          <p:cNvPr id="28" name="Can 27"/>
           <p:cNvSpPr/>
           <p:nvPr/>
         </p:nvSpPr>
         <p:spPr>
           <a:xfrm>
-            <a:off x="4633722" y="4050791"/>
-            <a:ext cx="1053846" cy="621792"/>
+            <a:off x="502920" y="4983480"/>
+            <a:ext cx="1371600" cy="658368"/>
+          </a:xfrm>
+          <a:prstGeom prst="can">
+            <a:avLst/>
+          </a:prstGeom>
+          <a:solidFill>
+            <a:srgbClr val="2C5F9E"/>
+          </a:solidFill>
+          <a:ln>
+            <a:noFill/>
+          </a:ln>
+          <a:effectLst/>
+        </p:spPr>
+        <p:style>
+          <a:lnRef idx="1">
+            <a:schemeClr val="accent1"/>
+          </a:lnRef>
+          <a:fillRef idx="3">
+            <a:schemeClr val="accent1"/>
+          </a:fillRef>
+          <a:effectRef idx="2">
+            <a:schemeClr val="accent1"/>
+          </a:effectRef>
+          <a:fontRef idx="minor">
+            <a:schemeClr val="lt1"/>
+          </a:fontRef>
+        </p:style>
+        <p:txBody>
+          <a:bodyPr rtlCol="0" anchor="ctr" wrap="square" lIns="25400" rIns="25400" tIns="12700" bIns="12700"/>
+          <a:lstStyle/>
+          <a:p>
+            <a:pPr algn="ctr"/>
+            <a:r>
+              <a:rPr sz="900" b="1">
+                <a:solidFill>
+                  <a:srgbClr val="FFFFFF"/>
+                </a:solidFill>
+                <a:latin typeface="微软雅黑"/>
+                <a:ea typeface="微软雅黑"/>
+              </a:rPr>
+              <a:t>专家/技能</a:t>
+            </a:r>
+          </a:p>
+          <a:p>
+            <a:pPr algn="ctr"/>
+            <a:r>
+              <a:rPr sz="900" b="1">
+                <a:solidFill>
+                  <a:srgbClr val="FFFFFF"/>
+                </a:solidFill>
+                <a:latin typeface="微软雅黑"/>
+                <a:ea typeface="微软雅黑"/>
+              </a:rPr>
+              <a:t>资产库</a:t>
+            </a:r>
+          </a:p>
+        </p:txBody>
+      </p:sp>
+      <p:sp>
+        <p:nvSpPr>
+          <p:cNvPr id="29" name="Rounded Rectangle 28"/>
+          <p:cNvSpPr/>
+          <p:nvPr/>
+        </p:nvSpPr>
+        <p:spPr>
+          <a:xfrm>
+            <a:off x="2468880" y="5029200"/>
+            <a:ext cx="1280160" cy="566928"/>
           </a:xfrm>
           <a:prstGeom prst="roundRect">
             <a:avLst>
-              <a:gd name="adj" fmla="val 16000"/>
+              <a:gd name="adj" fmla="val 12000"/>
             </a:avLst>
           </a:prstGeom>
           <a:solidFill>
@@ -4442,7 +4343,7 @@
           </a:solidFill>
           <a:ln w="12700">
             <a:solidFill>
-              <a:srgbClr val="1F7A6D"/>
+              <a:srgbClr val="1F2A3A"/>
             </a:solidFill>
           </a:ln>
           <a:effectLst/>
@@ -4462,38 +4363,450 @@
           </a:fontRef>
         </p:style>
         <p:txBody>
-          <a:bodyPr rtlCol="0" anchor="ctr" wrap="square" lIns="50800" rIns="50800" tIns="25400" bIns="25400"/>
+          <a:bodyPr rtlCol="0" anchor="ctr" wrap="square" lIns="25400" rIns="25400" tIns="12700" bIns="12700"/>
           <a:lstStyle/>
           <a:p>
             <a:pPr algn="ctr"/>
             <a:r>
-              <a:rPr sz="950" b="0">
+              <a:rPr sz="1000" b="1">
                 <a:solidFill>
                   <a:srgbClr val="1F2A3A"/>
                 </a:solidFill>
                 <a:latin typeface="微软雅黑"/>
                 <a:ea typeface="微软雅黑"/>
               </a:rPr>
-              <a:t>例行化
-定时/事件触发</a:t>
-            </a:r>
-          </a:p>
-        </p:txBody>
-      </p:sp>
-      <p:sp>
-        <p:nvSpPr>
-          <p:cNvPr id="29" name="Rounded Rectangle 28"/>
+              <a:t>统一交付</a:t>
+            </a:r>
+          </a:p>
+          <a:p>
+            <a:pPr algn="ctr"/>
+            <a:r>
+              <a:rPr sz="850" b="0">
+                <a:solidFill>
+                  <a:srgbClr val="5A6472"/>
+                </a:solidFill>
+                <a:latin typeface="微软雅黑"/>
+                <a:ea typeface="微软雅黑"/>
+              </a:rPr>
+              <a:t>结果可审计</a:t>
+            </a:r>
+          </a:p>
+        </p:txBody>
+      </p:sp>
+      <p:sp>
+        <p:nvSpPr>
+          <p:cNvPr id="30" name="Can 29"/>
           <p:cNvSpPr/>
           <p:nvPr/>
         </p:nvSpPr>
         <p:spPr>
           <a:xfrm>
-            <a:off x="320040" y="4773168"/>
-            <a:ext cx="841248" cy="932688"/>
+            <a:off x="4315968" y="4983480"/>
+            <a:ext cx="1371600" cy="658368"/>
+          </a:xfrm>
+          <a:prstGeom prst="can">
+            <a:avLst/>
+          </a:prstGeom>
+          <a:solidFill>
+            <a:srgbClr val="1F7A6D"/>
+          </a:solidFill>
+          <a:ln>
+            <a:noFill/>
+          </a:ln>
+          <a:effectLst/>
+        </p:spPr>
+        <p:style>
+          <a:lnRef idx="1">
+            <a:schemeClr val="accent1"/>
+          </a:lnRef>
+          <a:fillRef idx="3">
+            <a:schemeClr val="accent1"/>
+          </a:fillRef>
+          <a:effectRef idx="2">
+            <a:schemeClr val="accent1"/>
+          </a:effectRef>
+          <a:fontRef idx="minor">
+            <a:schemeClr val="lt1"/>
+          </a:fontRef>
+        </p:style>
+        <p:txBody>
+          <a:bodyPr rtlCol="0" anchor="ctr" wrap="square" lIns="25400" rIns="25400" tIns="12700" bIns="12700"/>
+          <a:lstStyle/>
+          <a:p>
+            <a:pPr algn="ctr"/>
+            <a:r>
+              <a:rPr sz="900" b="1">
+                <a:solidFill>
+                  <a:srgbClr val="FFFFFF"/>
+                </a:solidFill>
+                <a:latin typeface="微软雅黑"/>
+                <a:ea typeface="微软雅黑"/>
+              </a:rPr>
+              <a:t>团队蓝图库</a:t>
+            </a:r>
+          </a:p>
+          <a:p>
+            <a:pPr algn="ctr"/>
+            <a:r>
+              <a:rPr sz="850" b="0">
+                <a:solidFill>
+                  <a:srgbClr val="FFFFFF"/>
+                </a:solidFill>
+                <a:latin typeface="微软雅黑"/>
+                <a:ea typeface="微软雅黑"/>
+              </a:rPr>
+              <a:t>(版本化)</a:t>
+            </a:r>
+          </a:p>
+        </p:txBody>
+      </p:sp>
+      <p:cxnSp>
+        <p:nvCxnSpPr>
+          <p:cNvPr id="31" name="Connector 30"/>
+          <p:cNvCxnSpPr/>
+          <p:nvPr/>
+        </p:nvCxnSpPr>
+        <p:spPr>
+          <a:xfrm>
+            <a:off x="1097280" y="3566160"/>
+            <a:ext cx="1463040" cy="1463040"/>
+          </a:xfrm>
+          <a:prstGeom prst="line">
+            <a:avLst/>
+          </a:prstGeom>
+          <a:ln w="19050">
+            <a:solidFill>
+              <a:srgbClr val="5A6472"/>
+            </a:solidFill>
+            <a:tailEnd type="triangle" w="med" len="med"/>
+          </a:ln>
+          <a:effectLst/>
+        </p:spPr>
+        <p:style>
+          <a:lnRef idx="2">
+            <a:schemeClr val="accent1"/>
+          </a:lnRef>
+          <a:fillRef idx="0">
+            <a:schemeClr val="accent1"/>
+          </a:fillRef>
+          <a:effectRef idx="1">
+            <a:schemeClr val="accent1"/>
+          </a:effectRef>
+          <a:fontRef idx="minor">
+            <a:schemeClr val="tx1"/>
+          </a:fontRef>
+        </p:style>
+      </p:cxnSp>
+      <p:cxnSp>
+        <p:nvCxnSpPr>
+          <p:cNvPr id="32" name="Connector 31"/>
+          <p:cNvCxnSpPr/>
+          <p:nvPr/>
+        </p:nvCxnSpPr>
+        <p:spPr>
+          <a:xfrm flipH="1">
+            <a:off x="3246120" y="4617720"/>
+            <a:ext cx="274320" cy="411480"/>
+          </a:xfrm>
+          <a:prstGeom prst="line">
+            <a:avLst/>
+          </a:prstGeom>
+          <a:ln w="19050">
+            <a:solidFill>
+              <a:srgbClr val="1F7A6D"/>
+            </a:solidFill>
+            <a:tailEnd type="triangle" w="med" len="med"/>
+          </a:ln>
+          <a:effectLst/>
+        </p:spPr>
+        <p:style>
+          <a:lnRef idx="2">
+            <a:schemeClr val="accent1"/>
+          </a:lnRef>
+          <a:fillRef idx="0">
+            <a:schemeClr val="accent1"/>
+          </a:fillRef>
+          <a:effectRef idx="1">
+            <a:schemeClr val="accent1"/>
+          </a:effectRef>
+          <a:fontRef idx="minor">
+            <a:schemeClr val="tx1"/>
+          </a:fontRef>
+        </p:style>
+      </p:cxnSp>
+      <p:cxnSp>
+        <p:nvCxnSpPr>
+          <p:cNvPr id="33" name="Connector 32"/>
+          <p:cNvCxnSpPr/>
+          <p:nvPr/>
+        </p:nvCxnSpPr>
+        <p:spPr>
+          <a:xfrm flipV="1">
+            <a:off x="1417320" y="4617720"/>
+            <a:ext cx="1280160" cy="365760"/>
+          </a:xfrm>
+          <a:prstGeom prst="line">
+            <a:avLst/>
+          </a:prstGeom>
+          <a:ln w="19050">
+            <a:solidFill>
+              <a:srgbClr val="2C5F9E"/>
+            </a:solidFill>
+            <a:prstDash val="dash"/>
+            <a:tailEnd type="triangle" w="med" len="med"/>
+          </a:ln>
+          <a:effectLst/>
+        </p:spPr>
+        <p:style>
+          <a:lnRef idx="2">
+            <a:schemeClr val="accent1"/>
+          </a:lnRef>
+          <a:fillRef idx="0">
+            <a:schemeClr val="accent1"/>
+          </a:fillRef>
+          <a:effectRef idx="1">
+            <a:schemeClr val="accent1"/>
+          </a:effectRef>
+          <a:fontRef idx="minor">
+            <a:schemeClr val="tx1"/>
+          </a:fontRef>
+        </p:style>
+      </p:cxnSp>
+      <p:sp>
+        <p:nvSpPr>
+          <p:cNvPr id="34" name="TextBox 33"/>
+          <p:cNvSpPr txBox="1"/>
+          <p:nvPr/>
+        </p:nvSpPr>
+        <p:spPr>
+          <a:xfrm>
+            <a:off x="1005840" y="4681728"/>
+            <a:ext cx="1554480" cy="228600"/>
+          </a:xfrm>
+          <a:prstGeom prst="rect">
+            <a:avLst/>
+          </a:prstGeom>
+          <a:noFill/>
+        </p:spPr>
+        <p:txBody>
+          <a:bodyPr wrap="square" anchor="ctr" lIns="25400" rIns="25400" tIns="12700" bIns="12700">
+            <a:spAutoFit/>
+          </a:bodyPr>
+          <a:lstStyle/>
+          <a:p>
+            <a:pPr algn="ctr"/>
+            <a:r>
+              <a:rPr sz="800" b="0">
+                <a:solidFill>
+                  <a:srgbClr val="2C5F9E"/>
+                </a:solidFill>
+                <a:latin typeface="微软雅黑"/>
+                <a:ea typeface="微软雅黑"/>
+              </a:rPr>
+              <a:t>专家实例化组队</a:t>
+            </a:r>
+          </a:p>
+        </p:txBody>
+      </p:sp>
+      <p:cxnSp>
+        <p:nvCxnSpPr>
+          <p:cNvPr id="35" name="Connector 34"/>
+          <p:cNvCxnSpPr/>
+          <p:nvPr/>
+        </p:nvCxnSpPr>
+        <p:spPr>
+          <a:xfrm>
+            <a:off x="4617720" y="4617720"/>
+            <a:ext cx="274320" cy="365760"/>
+          </a:xfrm>
+          <a:prstGeom prst="line">
+            <a:avLst/>
+          </a:prstGeom>
+          <a:ln w="19050">
+            <a:solidFill>
+              <a:srgbClr val="1F7A6D"/>
+            </a:solidFill>
+            <a:prstDash val="dash"/>
+            <a:tailEnd type="triangle" w="med" len="med"/>
+          </a:ln>
+          <a:effectLst/>
+        </p:spPr>
+        <p:style>
+          <a:lnRef idx="2">
+            <a:schemeClr val="accent1"/>
+          </a:lnRef>
+          <a:fillRef idx="0">
+            <a:schemeClr val="accent1"/>
+          </a:fillRef>
+          <a:effectRef idx="1">
+            <a:schemeClr val="accent1"/>
+          </a:effectRef>
+          <a:fontRef idx="minor">
+            <a:schemeClr val="tx1"/>
+          </a:fontRef>
+        </p:style>
+      </p:cxnSp>
+      <p:sp>
+        <p:nvSpPr>
+          <p:cNvPr id="36" name="TextBox 35"/>
+          <p:cNvSpPr txBox="1"/>
+          <p:nvPr/>
+        </p:nvSpPr>
+        <p:spPr>
+          <a:xfrm>
+            <a:off x="4681728" y="4681728"/>
+            <a:ext cx="1097280" cy="228600"/>
+          </a:xfrm>
+          <a:prstGeom prst="rect">
+            <a:avLst/>
+          </a:prstGeom>
+          <a:noFill/>
+        </p:spPr>
+        <p:txBody>
+          <a:bodyPr wrap="square" anchor="ctr" lIns="25400" rIns="25400" tIns="12700" bIns="12700">
+            <a:spAutoFit/>
+          </a:bodyPr>
+          <a:lstStyle/>
+          <a:p>
+            <a:pPr algn="ctr"/>
+            <a:r>
+              <a:rPr sz="800" b="0">
+                <a:solidFill>
+                  <a:srgbClr val="1F7A6D"/>
+                </a:solidFill>
+                <a:latin typeface="微软雅黑"/>
+                <a:ea typeface="微软雅黑"/>
+              </a:rPr>
+              <a:t>执行后固化</a:t>
+            </a:r>
+          </a:p>
+        </p:txBody>
+      </p:sp>
+      <p:cxnSp>
+        <p:nvCxnSpPr>
+          <p:cNvPr id="37" name="Connector 36"/>
+          <p:cNvCxnSpPr/>
+          <p:nvPr/>
+        </p:nvCxnSpPr>
+        <p:spPr>
+          <a:xfrm flipV="1">
+            <a:off x="5705856" y="1591056"/>
+            <a:ext cx="0" cy="3529584"/>
+          </a:xfrm>
+          <a:prstGeom prst="line">
+            <a:avLst/>
+          </a:prstGeom>
+          <a:ln w="19050">
+            <a:solidFill>
+              <a:srgbClr val="1F7A6D"/>
+            </a:solidFill>
+            <a:prstDash val="dash"/>
+          </a:ln>
+          <a:effectLst/>
+        </p:spPr>
+        <p:style>
+          <a:lnRef idx="2">
+            <a:schemeClr val="accent1"/>
+          </a:lnRef>
+          <a:fillRef idx="0">
+            <a:schemeClr val="accent1"/>
+          </a:fillRef>
+          <a:effectRef idx="1">
+            <a:schemeClr val="accent1"/>
+          </a:effectRef>
+          <a:fontRef idx="minor">
+            <a:schemeClr val="tx1"/>
+          </a:fontRef>
+        </p:style>
+      </p:cxnSp>
+      <p:cxnSp>
+        <p:nvCxnSpPr>
+          <p:cNvPr id="38" name="Connector 37"/>
+          <p:cNvCxnSpPr/>
+          <p:nvPr/>
+        </p:nvCxnSpPr>
+        <p:spPr>
+          <a:xfrm flipH="1">
+            <a:off x="4315968" y="1591056"/>
+            <a:ext cx="1389888" cy="0"/>
+          </a:xfrm>
+          <a:prstGeom prst="line">
+            <a:avLst/>
+          </a:prstGeom>
+          <a:ln w="19050">
+            <a:solidFill>
+              <a:srgbClr val="1F7A6D"/>
+            </a:solidFill>
+            <a:prstDash val="dash"/>
+            <a:tailEnd type="triangle" w="med" len="med"/>
+          </a:ln>
+          <a:effectLst/>
+        </p:spPr>
+        <p:style>
+          <a:lnRef idx="2">
+            <a:schemeClr val="accent1"/>
+          </a:lnRef>
+          <a:fillRef idx="0">
+            <a:schemeClr val="accent1"/>
+          </a:fillRef>
+          <a:effectRef idx="1">
+            <a:schemeClr val="accent1"/>
+          </a:effectRef>
+          <a:fontRef idx="minor">
+            <a:schemeClr val="tx1"/>
+          </a:fontRef>
+        </p:style>
+      </p:cxnSp>
+      <p:sp>
+        <p:nvSpPr>
+          <p:cNvPr id="39" name="TextBox 38"/>
+          <p:cNvSpPr txBox="1"/>
+          <p:nvPr/>
+        </p:nvSpPr>
+        <p:spPr>
+          <a:xfrm>
+            <a:off x="4224528" y="1847088"/>
+            <a:ext cx="1600200" cy="228600"/>
+          </a:xfrm>
+          <a:prstGeom prst="rect">
+            <a:avLst/>
+          </a:prstGeom>
+          <a:noFill/>
+        </p:spPr>
+        <p:txBody>
+          <a:bodyPr wrap="square" anchor="ctr" lIns="25400" rIns="25400" tIns="12700" bIns="12700">
+            <a:spAutoFit/>
+          </a:bodyPr>
+          <a:lstStyle/>
+          <a:p>
+            <a:pPr algn="ctr"/>
+            <a:r>
+              <a:rPr sz="800" b="0">
+                <a:solidFill>
+                  <a:srgbClr val="1F7A6D"/>
+                </a:solidFill>
+                <a:latin typeface="微软雅黑"/>
+                <a:ea typeface="微软雅黑"/>
+              </a:rPr>
+              <a:t>蓝图复用·例行触发</a:t>
+            </a:r>
+          </a:p>
+        </p:txBody>
+      </p:sp>
+      <p:sp>
+        <p:nvSpPr>
+          <p:cNvPr id="40" name="Rounded Rectangle 39"/>
+          <p:cNvSpPr/>
+          <p:nvPr/>
+        </p:nvSpPr>
+        <p:spPr>
+          <a:xfrm>
+            <a:off x="502920" y="5779008"/>
+            <a:ext cx="5202936" cy="420624"/>
           </a:xfrm>
           <a:prstGeom prst="roundRect">
             <a:avLst>
-              <a:gd name="adj" fmla="val 8000"/>
+              <a:gd name="adj" fmla="val 12000"/>
             </a:avLst>
           </a:prstGeom>
           <a:solidFill>
@@ -4519,81 +4832,33 @@
           </a:fontRef>
         </p:style>
         <p:txBody>
-          <a:bodyPr rtlCol="0" anchor="ctr" wrap="square" lIns="50800" rIns="50800" tIns="25400" bIns="25400"/>
+          <a:bodyPr rtlCol="0" anchor="ctr" wrap="square" lIns="25400" rIns="25400" tIns="12700" bIns="12700"/>
           <a:lstStyle/>
           <a:p>
             <a:pPr algn="ctr"/>
             <a:r>
-              <a:rPr sz="1150" b="1">
+              <a:rPr sz="1000" b="1">
                 <a:solidFill>
                   <a:srgbClr val="FFFFFF"/>
                 </a:solidFill>
                 <a:latin typeface="微软雅黑"/>
                 <a:ea typeface="微软雅黑"/>
               </a:rPr>
-              <a:t>底座</a:t>
-            </a:r>
-          </a:p>
-        </p:txBody>
-      </p:sp>
-      <p:sp>
-        <p:nvSpPr>
-          <p:cNvPr id="30" name="Rounded Rectangle 29"/>
-          <p:cNvSpPr/>
-          <p:nvPr/>
-        </p:nvSpPr>
-        <p:spPr>
-          <a:xfrm>
-            <a:off x="1234440" y="4773168"/>
-            <a:ext cx="4526280" cy="932688"/>
-          </a:xfrm>
-          <a:prstGeom prst="roundRect">
-            <a:avLst>
-              <a:gd name="adj" fmla="val 8000"/>
-            </a:avLst>
-          </a:prstGeom>
-          <a:solidFill>
-            <a:srgbClr val="F2F5F9"/>
-          </a:solidFill>
-          <a:ln w="12700">
-            <a:solidFill>
-              <a:srgbClr val="4A5568"/>
-            </a:solidFill>
-          </a:ln>
-          <a:effectLst/>
-        </p:spPr>
-        <p:style>
-          <a:lnRef idx="1">
-            <a:schemeClr val="accent1"/>
-          </a:lnRef>
-          <a:fillRef idx="3">
-            <a:schemeClr val="accent1"/>
-          </a:fillRef>
-          <a:effectRef idx="2">
-            <a:schemeClr val="accent1"/>
-          </a:effectRef>
-          <a:fontRef idx="minor">
-            <a:schemeClr val="lt1"/>
-          </a:fontRef>
-        </p:style>
-        <p:txBody>
-          <a:bodyPr rtlCol="0" anchor="ctr"/>
-          <a:lstStyle/>
-          <a:p>
-            <a:pPr algn="ctr"/>
-          </a:p>
-        </p:txBody>
-      </p:sp>
-      <p:sp>
-        <p:nvSpPr>
-          <p:cNvPr id="31" name="TextBox 30"/>
+              <a:t>企业级治理底座:权限审计 · 成本配额 · 效果度量(ROI) · 共享记忆</a:t>
+            </a:r>
+          </a:p>
+        </p:txBody>
+      </p:sp>
+      <p:sp>
+        <p:nvSpPr>
+          <p:cNvPr id="41" name="TextBox 40"/>
           <p:cNvSpPr txBox="1"/>
           <p:nvPr/>
         </p:nvSpPr>
         <p:spPr>
           <a:xfrm>
-            <a:off x="1307592" y="4791455"/>
-            <a:ext cx="4379976" cy="237744"/>
+            <a:off x="502920" y="6254496"/>
+            <a:ext cx="5212080" cy="274320"/>
           </a:xfrm>
           <a:prstGeom prst="rect">
             <a:avLst/>
@@ -4601,300 +4866,28 @@
           <a:noFill/>
         </p:spPr>
         <p:txBody>
-          <a:bodyPr wrap="square" anchor="ctr" lIns="50800" rIns="50800" tIns="25400" bIns="25400">
+          <a:bodyPr wrap="square" anchor="t" lIns="25400" rIns="25400" tIns="12700" bIns="12700">
             <a:spAutoFit/>
           </a:bodyPr>
           <a:lstStyle/>
           <a:p>
             <a:pPr algn="l"/>
             <a:r>
-              <a:rPr sz="1100" b="1">
-                <a:solidFill>
-                  <a:srgbClr val="4A5568"/>
-                </a:solidFill>
-                <a:latin typeface="微软雅黑"/>
-                <a:ea typeface="微软雅黑"/>
-              </a:rPr>
-              <a:t>企业级治理控制面(政企商用落地前提)</a:t>
-            </a:r>
-          </a:p>
-        </p:txBody>
-      </p:sp>
-      <p:sp>
-        <p:nvSpPr>
-          <p:cNvPr id="32" name="Rounded Rectangle 31"/>
-          <p:cNvSpPr/>
-          <p:nvPr/>
-        </p:nvSpPr>
-        <p:spPr>
-          <a:xfrm>
-            <a:off x="1307592" y="5047488"/>
-            <a:ext cx="1053846" cy="621792"/>
-          </a:xfrm>
-          <a:prstGeom prst="roundRect">
-            <a:avLst>
-              <a:gd name="adj" fmla="val 16000"/>
-            </a:avLst>
-          </a:prstGeom>
-          <a:solidFill>
-            <a:srgbClr val="FFFFFF"/>
-          </a:solidFill>
-          <a:ln w="12700">
-            <a:solidFill>
-              <a:srgbClr val="4A5568"/>
-            </a:solidFill>
-          </a:ln>
-          <a:effectLst/>
-        </p:spPr>
-        <p:style>
-          <a:lnRef idx="1">
-            <a:schemeClr val="accent1"/>
-          </a:lnRef>
-          <a:fillRef idx="3">
-            <a:schemeClr val="accent1"/>
-          </a:fillRef>
-          <a:effectRef idx="2">
-            <a:schemeClr val="accent1"/>
-          </a:effectRef>
-          <a:fontRef idx="minor">
-            <a:schemeClr val="lt1"/>
-          </a:fontRef>
-        </p:style>
-        <p:txBody>
-          <a:bodyPr rtlCol="0" anchor="ctr" wrap="square" lIns="50800" rIns="50800" tIns="25400" bIns="25400"/>
-          <a:lstStyle/>
-          <a:p>
-            <a:pPr algn="ctr"/>
-            <a:r>
-              <a:rPr sz="950" b="0">
-                <a:solidFill>
-                  <a:srgbClr val="1F2A3A"/>
-                </a:solidFill>
-                <a:latin typeface="微软雅黑"/>
-                <a:ea typeface="微软雅黑"/>
-              </a:rPr>
-              <a:t>权限与
-审计</a:t>
-            </a:r>
-          </a:p>
-        </p:txBody>
-      </p:sp>
-      <p:sp>
-        <p:nvSpPr>
-          <p:cNvPr id="33" name="Rounded Rectangle 32"/>
-          <p:cNvSpPr/>
-          <p:nvPr/>
-        </p:nvSpPr>
-        <p:spPr>
-          <a:xfrm>
-            <a:off x="2416302" y="5047488"/>
-            <a:ext cx="1053846" cy="621792"/>
-          </a:xfrm>
-          <a:prstGeom prst="roundRect">
-            <a:avLst>
-              <a:gd name="adj" fmla="val 16000"/>
-            </a:avLst>
-          </a:prstGeom>
-          <a:solidFill>
-            <a:srgbClr val="FFFFFF"/>
-          </a:solidFill>
-          <a:ln w="12700">
-            <a:solidFill>
-              <a:srgbClr val="4A5568"/>
-            </a:solidFill>
-          </a:ln>
-          <a:effectLst/>
-        </p:spPr>
-        <p:style>
-          <a:lnRef idx="1">
-            <a:schemeClr val="accent1"/>
-          </a:lnRef>
-          <a:fillRef idx="3">
-            <a:schemeClr val="accent1"/>
-          </a:fillRef>
-          <a:effectRef idx="2">
-            <a:schemeClr val="accent1"/>
-          </a:effectRef>
-          <a:fontRef idx="minor">
-            <a:schemeClr val="lt1"/>
-          </a:fontRef>
-        </p:style>
-        <p:txBody>
-          <a:bodyPr rtlCol="0" anchor="ctr" wrap="square" lIns="50800" rIns="50800" tIns="25400" bIns="25400"/>
-          <a:lstStyle/>
-          <a:p>
-            <a:pPr algn="ctr"/>
-            <a:r>
-              <a:rPr sz="950" b="0">
-                <a:solidFill>
-                  <a:srgbClr val="1F2A3A"/>
-                </a:solidFill>
-                <a:latin typeface="微软雅黑"/>
-                <a:ea typeface="微软雅黑"/>
-              </a:rPr>
-              <a:t>成本配额
-管控</a:t>
-            </a:r>
-          </a:p>
-        </p:txBody>
-      </p:sp>
-      <p:sp>
-        <p:nvSpPr>
-          <p:cNvPr id="34" name="Rounded Rectangle 33"/>
-          <p:cNvSpPr/>
-          <p:nvPr/>
-        </p:nvSpPr>
-        <p:spPr>
-          <a:xfrm>
-            <a:off x="3525012" y="5047488"/>
-            <a:ext cx="1053846" cy="621792"/>
-          </a:xfrm>
-          <a:prstGeom prst="roundRect">
-            <a:avLst>
-              <a:gd name="adj" fmla="val 16000"/>
-            </a:avLst>
-          </a:prstGeom>
-          <a:solidFill>
-            <a:srgbClr val="FFFFFF"/>
-          </a:solidFill>
-          <a:ln w="12700">
-            <a:solidFill>
-              <a:srgbClr val="4A5568"/>
-            </a:solidFill>
-          </a:ln>
-          <a:effectLst/>
-        </p:spPr>
-        <p:style>
-          <a:lnRef idx="1">
-            <a:schemeClr val="accent1"/>
-          </a:lnRef>
-          <a:fillRef idx="3">
-            <a:schemeClr val="accent1"/>
-          </a:fillRef>
-          <a:effectRef idx="2">
-            <a:schemeClr val="accent1"/>
-          </a:effectRef>
-          <a:fontRef idx="minor">
-            <a:schemeClr val="lt1"/>
-          </a:fontRef>
-        </p:style>
-        <p:txBody>
-          <a:bodyPr rtlCol="0" anchor="ctr" wrap="square" lIns="50800" rIns="50800" tIns="25400" bIns="25400"/>
-          <a:lstStyle/>
-          <a:p>
-            <a:pPr algn="ctr"/>
-            <a:r>
-              <a:rPr sz="950" b="0">
-                <a:solidFill>
-                  <a:srgbClr val="1F2A3A"/>
-                </a:solidFill>
-                <a:latin typeface="微软雅黑"/>
-                <a:ea typeface="微软雅黑"/>
-              </a:rPr>
-              <a:t>效果度量
-ROI 看板</a:t>
-            </a:r>
-          </a:p>
-        </p:txBody>
-      </p:sp>
-      <p:sp>
-        <p:nvSpPr>
-          <p:cNvPr id="35" name="Rounded Rectangle 34"/>
-          <p:cNvSpPr/>
-          <p:nvPr/>
-        </p:nvSpPr>
-        <p:spPr>
-          <a:xfrm>
-            <a:off x="4633722" y="5047488"/>
-            <a:ext cx="1053846" cy="621792"/>
-          </a:xfrm>
-          <a:prstGeom prst="roundRect">
-            <a:avLst>
-              <a:gd name="adj" fmla="val 16000"/>
-            </a:avLst>
-          </a:prstGeom>
-          <a:solidFill>
-            <a:srgbClr val="FFFFFF"/>
-          </a:solidFill>
-          <a:ln w="12700">
-            <a:solidFill>
-              <a:srgbClr val="4A5568"/>
-            </a:solidFill>
-          </a:ln>
-          <a:effectLst/>
-        </p:spPr>
-        <p:style>
-          <a:lnRef idx="1">
-            <a:schemeClr val="accent1"/>
-          </a:lnRef>
-          <a:fillRef idx="3">
-            <a:schemeClr val="accent1"/>
-          </a:fillRef>
-          <a:effectRef idx="2">
-            <a:schemeClr val="accent1"/>
-          </a:effectRef>
-          <a:fontRef idx="minor">
-            <a:schemeClr val="lt1"/>
-          </a:fontRef>
-        </p:style>
-        <p:txBody>
-          <a:bodyPr rtlCol="0" anchor="ctr" wrap="square" lIns="50800" rIns="50800" tIns="25400" bIns="25400"/>
-          <a:lstStyle/>
-          <a:p>
-            <a:pPr algn="ctr"/>
-            <a:r>
-              <a:rPr sz="950" b="0">
-                <a:solidFill>
-                  <a:srgbClr val="1F2A3A"/>
-                </a:solidFill>
-                <a:latin typeface="微软雅黑"/>
-                <a:ea typeface="微软雅黑"/>
-              </a:rPr>
-              <a:t>共享记忆
-上下文空间</a:t>
-            </a:r>
-          </a:p>
-        </p:txBody>
-      </p:sp>
-      <p:sp>
-        <p:nvSpPr>
-          <p:cNvPr id="36" name="TextBox 35"/>
-          <p:cNvSpPr txBox="1"/>
-          <p:nvPr/>
-        </p:nvSpPr>
-        <p:spPr>
-          <a:xfrm>
-            <a:off x="320040" y="5751576"/>
-            <a:ext cx="5440680" cy="457200"/>
-          </a:xfrm>
-          <a:prstGeom prst="rect">
-            <a:avLst/>
-          </a:prstGeom>
-          <a:noFill/>
-        </p:spPr>
-        <p:txBody>
-          <a:bodyPr wrap="square" anchor="t" lIns="50800" rIns="50800" tIns="25400" bIns="25400">
-            <a:spAutoFit/>
-          </a:bodyPr>
-          <a:lstStyle/>
-          <a:p>
-            <a:pPr algn="l"/>
-            <a:r>
-              <a:rPr sz="950" b="0">
+              <a:rPr sz="850" b="0">
                 <a:solidFill>
                   <a:srgbClr val="5A6472"/>
                 </a:solidFill>
                 <a:latin typeface="微软雅黑"/>
                 <a:ea typeface="微软雅黑"/>
               </a:rPr>
-              <a:t>架构原则:写操作单线程 + 多 Agent 贡献智能(map-reduce-and-manage),规避并行写冲突与成本失控</a:t>
-            </a:r>
-          </a:p>
-        </p:txBody>
-      </p:sp>
-      <p:sp>
-        <p:nvSpPr>
-          <p:cNvPr id="37" name="TextBox 36"/>
+              <a:t>实线 = 任务流    虚线 = 资产/反馈流    架构原则:写操作单线程 + 多 Agent 贡献智能</a:t>
+            </a:r>
+          </a:p>
+        </p:txBody>
+      </p:sp>
+      <p:sp>
+        <p:nvSpPr>
+          <p:cNvPr id="42" name="TextBox 41"/>
           <p:cNvSpPr txBox="1"/>
           <p:nvPr/>
         </p:nvSpPr>
@@ -4909,7 +4902,7 @@
           <a:noFill/>
         </p:spPr>
         <p:txBody>
-          <a:bodyPr wrap="square" anchor="ctr" lIns="50800" rIns="50800" tIns="25400" bIns="25400">
+          <a:bodyPr wrap="square" anchor="ctr" lIns="25400" rIns="25400" tIns="12700" bIns="12700">
             <a:spAutoFit/>
           </a:bodyPr>
           <a:lstStyle/>
@@ -4930,7 +4923,7 @@
       </p:sp>
       <p:graphicFrame>
         <p:nvGraphicFramePr>
-          <p:cNvPr id="38" name="Table 37"/>
+          <p:cNvPr id="43" name="Table 42"/>
           <p:cNvGraphicFramePr>
             <a:graphicFrameLocks noGrp="1"/>
           </p:cNvGraphicFramePr>
@@ -5306,7 +5299,7 @@
       </p:graphicFrame>
       <p:sp>
         <p:nvSpPr>
-          <p:cNvPr id="39" name="TextBox 38"/>
+          <p:cNvPr id="44" name="TextBox 43"/>
           <p:cNvSpPr txBox="1"/>
           <p:nvPr/>
         </p:nvSpPr>
@@ -5321,7 +5314,7 @@
           <a:noFill/>
         </p:spPr>
         <p:txBody>
-          <a:bodyPr wrap="square" anchor="t" lIns="50800" rIns="50800" tIns="25400" bIns="25400">
+          <a:bodyPr wrap="square" anchor="t" lIns="25400" rIns="25400" tIns="12700" bIns="12700">
             <a:spAutoFit/>
           </a:bodyPr>
           <a:lstStyle/>

</xml_diff>